<commit_message>
Updating methods with finalized DVs
</commit_message>
<xml_diff>
--- a/docs/NYCOptimization_project_proposal_and_motivation_CLAUDE.pptx
+++ b/docs/NYCOptimization_project_proposal_and_motivation_CLAUDE.pptx
@@ -2233,7 +2233,7 @@
           <a:lstStyle/>
           <a:p>
             <a:r>
-              <a:t>Weekly satisficing frequency; annual failure-year frequency in ensemble mode.</a:t>
+              <a:t>Annual failure-year frequency vs the running-average entitlement; same objective for every design.</a:t>
             </a:r>
           </a:p>
         </p:txBody>
@@ -2303,7 +2303,7 @@
           <a:lstStyle/>
           <a:p>
             <a:r>
-              <a:t>CVaR90 tail deficit.</a:t>
+              <a:t>Within-year CVaR90, then worst-1%-unit-year across the pool.</a:t>
             </a:r>
           </a:p>
         </p:txBody>
@@ -2373,7 +2373,7 @@
           <a:lstStyle/>
           <a:p>
             <a:r>
-              <a:t>Weekly reliability vs static Decree target.</a:t>
+              <a:t>Annual failure-year frequency vs static Decree target.</a:t>
             </a:r>
           </a:p>
         </p:txBody>
@@ -2443,7 +2443,7 @@
           <a:lstStyle/>
           <a:p>
             <a:r>
-              <a:t>CVaR90 of Montague deficit.</a:t>
+              <a:t>Within-year CVaR90, then worst-1%-unit-year.</a:t>
             </a:r>
           </a:p>
         </p:txBody>
@@ -2583,7 +2583,7 @@
           <a:lstStyle/>
           <a:p>
             <a:r>
-              <a:t>Flood day count at minor stage.</a:t>
+              <a:t>Expected annual flood days at minor stage.</a:t>
             </a:r>
           </a:p>
         </p:txBody>
@@ -2653,7 +2653,7 @@
           <a:lstStyle/>
           <a:p>
             <a:r>
-              <a:t>Storage P5; ensemble P01 of annual minima.</a:t>
+              <a:t>Annual minimum storage, then P01 across the pool.</a:t>
             </a:r>
           </a:p>
         </p:txBody>
@@ -31505,7 +31505,7 @@
                 </a:solidFill>
                 <a:latin typeface="Cambria"/>
               </a:rPr>
-              <a:t>reliability = (weeks meeting the goal) ÷ (total weeks)</a:t>
+              <a:t>unit-year = one water year (Oct 1–Sep 30);  an L-yr record scores L−1 unit-years</a:t>
             </a:r>
           </a:p>
           <a:p>
@@ -31543,7 +31543,7 @@
                 </a:solidFill>
                 <a:latin typeface="Cambria"/>
               </a:rPr>
-              <a:t>P₅(series) = 5th-percentile value</a:t>
+              <a:t>P₉₉ / P₀₁(units) = worst / 1st-percentile unit-year</a:t>
             </a:r>
           </a:p>
         </p:txBody>
@@ -31605,6 +31605,25 @@
                 <a:latin typeface="Calibri"/>
               </a:rPr>
               <a:t>•  Decree goalposts: NYC 800 MGD; Montague 1,131.05 MGD (1,750 cfs); Trenton 1,938.95 MGD; NYC capacity 270,837 MG</a:t>
+            </a:r>
+          </a:p>
+          <a:p>
+            <a:pPr>
+              <a:lnSpc>
+                <a:spcPct val="104000"/>
+              </a:lnSpc>
+              <a:spcAft>
+                <a:spcPts val="1000"/>
+              </a:spcAft>
+            </a:pPr>
+            <a:r>
+              <a:rPr sz="1900" i="0" b="0">
+                <a:solidFill>
+                  <a:srgbClr val="212529"/>
+                </a:solidFill>
+                <a:latin typeface="Calibri"/>
+              </a:rPr>
+              <a:t>•  every objective is two-layer — an annual metric per unit-year, then a unit operator over the pooled unit-years. The SAME function for every design (historic = 1 record × 76 unit-years; ensembles = N × (L−1)), so only the scenario set varies</a:t>
             </a:r>
           </a:p>
         </p:txBody>
@@ -31742,7 +31761,7 @@
                 </a:solidFill>
                 <a:latin typeface="Cambria"/>
               </a:rPr>
-              <a:t>demand = min(NYC demand, 800 MGD)</a:t>
+              <a:t>entitlement:  Eₜ = min(demandₜ, allowanceₜ)      [allowance = running-avg bank]</a:t>
             </a:r>
           </a:p>
           <a:p>
@@ -31761,7 +31780,26 @@
                 </a:solidFill>
                 <a:latin typeface="Cambria"/>
               </a:rPr>
-              <a:t>f₁ = (weeks with delivery ≥ 99% of demand) ÷ (total weeks)</a:t>
+              <a:t>failing week:  Σ delivery &lt; 99% × Σ E       failure-year:  ≥ k failing weeks  (k = 1)</a:t>
+            </a:r>
+          </a:p>
+          <a:p>
+            <a:pPr>
+              <a:lnSpc>
+                <a:spcPct val="104000"/>
+              </a:lnSpc>
+              <a:spcAft>
+                <a:spcPts val="600"/>
+              </a:spcAft>
+            </a:pPr>
+            <a:r>
+              <a:rPr sz="2000" i="0" b="0">
+                <a:solidFill>
+                  <a:srgbClr val="212529"/>
+                </a:solidFill>
+                <a:latin typeface="Cambria"/>
+              </a:rPr>
+              <a:t>f₁ = (unit-years without failure) ÷ (total unit-years)</a:t>
             </a:r>
           </a:p>
         </p:txBody>
@@ -31774,8 +31812,8 @@
         </p:nvSpPr>
         <p:spPr>
           <a:xfrm>
-            <a:off x="548640" y="2560320"/>
-            <a:ext cx="11091672" cy="4069080"/>
+            <a:off x="548640" y="3017520"/>
+            <a:ext cx="11091672" cy="3611880"/>
           </a:xfrm>
           <a:prstGeom prst="rect">
             <a:avLst/>
@@ -31803,7 +31841,7 @@
                 </a:solidFill>
                 <a:latin typeface="Calibri"/>
               </a:rPr>
-              <a:t>•  weekly success rate; demand capped at the Decree right so voluntary low-takes don't count</a:t>
+              <a:t>•  the Decree caps the running AVERAGE diversion, not any single day — demand is never clipped at a flat 800 MGD, and a spike is owed whenever prior under-use has banked the allowance for it</a:t>
             </a:r>
           </a:p>
           <a:p>
@@ -31822,7 +31860,7 @@
                 </a:solidFill>
                 <a:latin typeface="Calibri"/>
               </a:rPr>
-              <a:t>•  success rates are stable, fast-converging search signals (Hashimoto et al. 1982; Herman et al. 2015)</a:t>
+              <a:t>•  the bank accrues 800 − delivery per day (reset Jun 1) at the STATIC Decree right, so a policy's own drought step-downs cannot lower its own goalpost</a:t>
             </a:r>
           </a:p>
           <a:p>
@@ -31841,7 +31879,26 @@
                 </a:solidFill>
                 <a:latin typeface="Calibri"/>
               </a:rPr>
-              <a:t>•  ensemble form: frequency of non-failure years (Zeff et al. 2014)</a:t>
+              <a:t>•  failure-year frequency is the citable search-time satisficing operator (Zeff et al. 2014; Trindade et al. 2017)</a:t>
+            </a:r>
+          </a:p>
+          <a:p>
+            <a:pPr>
+              <a:lnSpc>
+                <a:spcPct val="104000"/>
+              </a:lnSpc>
+              <a:spcAft>
+                <a:spcPts val="1000"/>
+              </a:spcAft>
+            </a:pPr>
+            <a:r>
+              <a:rPr sz="1900" i="0" b="0">
+                <a:solidFill>
+                  <a:srgbClr val="212529"/>
+                </a:solidFill>
+                <a:latin typeface="Calibri"/>
+              </a:rPr>
+              <a:t>•  re-evaluation metric: whole-record weekly reliability, per realization</a:t>
             </a:r>
           </a:p>
         </p:txBody>
@@ -31979,7 +32036,7 @@
                 </a:solidFill>
                 <a:latin typeface="Cambria"/>
               </a:rPr>
-              <a:t>weekly deficit = (demand − delivery)₊ ÷ 800 MGD × 100%</a:t>
+              <a:t>weekly deficit = (E − delivery)₊ ÷ 800 MGD × 100%</a:t>
             </a:r>
           </a:p>
           <a:p>
@@ -31998,7 +32055,26 @@
                 </a:solidFill>
                 <a:latin typeface="Cambria"/>
               </a:rPr>
-              <a:t>f₂ = CVaR₉₀ of weekly deficits</a:t>
+              <a:t>annual metric = CVaR₉₀ of that unit-year's weekly deficits</a:t>
+            </a:r>
+          </a:p>
+          <a:p>
+            <a:pPr>
+              <a:lnSpc>
+                <a:spcPct val="104000"/>
+              </a:lnSpc>
+              <a:spcAft>
+                <a:spcPts val="600"/>
+              </a:spcAft>
+            </a:pPr>
+            <a:r>
+              <a:rPr sz="2000" i="0" b="0">
+                <a:solidFill>
+                  <a:srgbClr val="212529"/>
+                </a:solidFill>
+                <a:latin typeface="Cambria"/>
+              </a:rPr>
+              <a:t>f₂ = P₉₉ across pooled unit-years   (worst 1st-percentile unit-year)</a:t>
             </a:r>
           </a:p>
         </p:txBody>
@@ -32011,8 +32087,8 @@
         </p:nvSpPr>
         <p:spPr>
           <a:xfrm>
-            <a:off x="548640" y="2560320"/>
-            <a:ext cx="11091672" cy="4069080"/>
+            <a:off x="548640" y="3017520"/>
+            <a:ext cx="11091672" cy="3611880"/>
           </a:xfrm>
           <a:prstGeom prst="rect">
             <a:avLst/>
@@ -32040,7 +32116,7 @@
                 </a:solidFill>
                 <a:latin typeface="Calibri"/>
               </a:rPr>
-              <a:t>•  magnitude of shortfalls, not just frequency; scaled to the fixed cap</a:t>
+              <a:t>•  magnitude of shortfalls below the running-average entitlement E, not just their frequency; scaled to the fixed 800 MGD right</a:t>
             </a:r>
           </a:p>
           <a:p>
@@ -32078,7 +32154,7 @@
                 </a:solidFill>
                 <a:latin typeface="Calibri"/>
               </a:rPr>
-              <a:t>•  ensemble form: worst 1st-percentile unit-year of within-year CVaR₉₀</a:t>
+              <a:t>•  re-evaluation metric: whole-record CVaR₉₀, per realization</a:t>
             </a:r>
           </a:p>
         </p:txBody>
@@ -32216,7 +32292,26 @@
                 </a:solidFill>
                 <a:latin typeface="Cambria"/>
               </a:rPr>
-              <a:t>f₃ = (weeks with flow ≥ 1,131.05 MGD) ÷ (total weeks)      [1,750 cfs]</a:t>
+              <a:t>failing week:  mean flow &lt; 1,131.05 MGD      [1,750 cfs]</a:t>
+            </a:r>
+          </a:p>
+          <a:p>
+            <a:pPr>
+              <a:lnSpc>
+                <a:spcPct val="104000"/>
+              </a:lnSpc>
+              <a:spcAft>
+                <a:spcPts val="600"/>
+              </a:spcAft>
+            </a:pPr>
+            <a:r>
+              <a:rPr sz="2000" i="0" b="0">
+                <a:solidFill>
+                  <a:srgbClr val="212529"/>
+                </a:solidFill>
+                <a:latin typeface="Cambria"/>
+              </a:rPr>
+              <a:t>f₃ = (unit-years with &lt; k failing weeks) ÷ (total unit-years)</a:t>
             </a:r>
           </a:p>
         </p:txBody>
@@ -32229,8 +32324,8 @@
         </p:nvSpPr>
         <p:spPr>
           <a:xfrm>
-            <a:off x="548640" y="2103120"/>
-            <a:ext cx="11091672" cy="4526280"/>
+            <a:off x="548640" y="2560320"/>
+            <a:ext cx="11091672" cy="4069080"/>
           </a:xfrm>
           <a:prstGeom prst="rect">
             <a:avLst/>
@@ -32258,7 +32353,7 @@
                 </a:solidFill>
                 <a:latin typeface="Calibri"/>
               </a:rPr>
-              <a:t>•  weekly success rate vs the fixed Decree target, never the live FFMP step-down target</a:t>
+              <a:t>•  vs the fixed Decree target, never the live FFMP step-down target</a:t>
             </a:r>
           </a:p>
           <a:p>
@@ -32296,7 +32391,26 @@
                 </a:solidFill>
                 <a:latin typeface="Calibri"/>
               </a:rPr>
-              <a:t>•  ensemble form: frequency of non-failure years (Zeff et al. 2014; Trindade et al. 2017)</a:t>
+              <a:t>•  failure-year frequency (Zeff et al. 2014; Trindade et al. 2017)</a:t>
+            </a:r>
+          </a:p>
+          <a:p>
+            <a:pPr>
+              <a:lnSpc>
+                <a:spcPct val="104000"/>
+              </a:lnSpc>
+              <a:spcAft>
+                <a:spcPts val="1000"/>
+              </a:spcAft>
+            </a:pPr>
+            <a:r>
+              <a:rPr sz="1900" i="0" b="0">
+                <a:solidFill>
+                  <a:srgbClr val="212529"/>
+                </a:solidFill>
+                <a:latin typeface="Calibri"/>
+              </a:rPr>
+              <a:t>•  re-evaluation metric: whole-record weekly reliability, per realization</a:t>
             </a:r>
           </a:p>
         </p:txBody>
@@ -32453,7 +32567,26 @@
                 </a:solidFill>
                 <a:latin typeface="Cambria"/>
               </a:rPr>
-              <a:t>f₄ = CVaR₉₀ of weekly deficits</a:t>
+              <a:t>annual metric = CVaR₉₀ of that unit-year's weekly deficits</a:t>
+            </a:r>
+          </a:p>
+          <a:p>
+            <a:pPr>
+              <a:lnSpc>
+                <a:spcPct val="104000"/>
+              </a:lnSpc>
+              <a:spcAft>
+                <a:spcPts val="600"/>
+              </a:spcAft>
+            </a:pPr>
+            <a:r>
+              <a:rPr sz="2000" i="0" b="0">
+                <a:solidFill>
+                  <a:srgbClr val="212529"/>
+                </a:solidFill>
+                <a:latin typeface="Cambria"/>
+              </a:rPr>
+              <a:t>f₄ = P₉₉ across pooled unit-years</a:t>
             </a:r>
           </a:p>
         </p:txBody>
@@ -32466,8 +32599,8 @@
         </p:nvSpPr>
         <p:spPr>
           <a:xfrm>
-            <a:off x="548640" y="2560320"/>
-            <a:ext cx="11091672" cy="4069080"/>
+            <a:off x="548640" y="3017520"/>
+            <a:ext cx="11091672" cy="3611880"/>
           </a:xfrm>
           <a:prstGeom prst="rect">
             <a:avLst/>
@@ -32533,7 +32666,7 @@
                 </a:solidFill>
                 <a:latin typeface="Calibri"/>
               </a:rPr>
-              <a:t>•  ensemble form: worst 1st-percentile unit-year</a:t>
+              <a:t>•  re-evaluation metric: whole-record CVaR₉₀, per realization</a:t>
             </a:r>
           </a:p>
         </p:txBody>
@@ -32671,7 +32804,26 @@
                 </a:solidFill>
                 <a:latin typeface="Cambria"/>
               </a:rPr>
-              <a:t>f₅ = (weeks with flow ≥ 1,938.95 MGD) ÷ (total weeks)</a:t>
+              <a:t>failing week:  mean flow &lt; 1,938.95 MGD</a:t>
+            </a:r>
+          </a:p>
+          <a:p>
+            <a:pPr>
+              <a:lnSpc>
+                <a:spcPct val="104000"/>
+              </a:lnSpc>
+              <a:spcAft>
+                <a:spcPts val="600"/>
+              </a:spcAft>
+            </a:pPr>
+            <a:r>
+              <a:rPr sz="2000" i="0" b="0">
+                <a:solidFill>
+                  <a:srgbClr val="212529"/>
+                </a:solidFill>
+                <a:latin typeface="Cambria"/>
+              </a:rPr>
+              <a:t>f₅ = (unit-years with &lt; k failing weeks) ÷ (total unit-years)</a:t>
             </a:r>
           </a:p>
         </p:txBody>
@@ -32684,8 +32836,8 @@
         </p:nvSpPr>
         <p:spPr>
           <a:xfrm>
-            <a:off x="548640" y="2103120"/>
-            <a:ext cx="11091672" cy="4526280"/>
+            <a:off x="548640" y="2560320"/>
+            <a:ext cx="11091672" cy="4069080"/>
           </a:xfrm>
           <a:prstGeom prst="rect">
             <a:avLst/>
@@ -32751,7 +32903,7 @@
                 </a:solidFill>
                 <a:latin typeface="Calibri"/>
               </a:rPr>
-              <a:t>•  ensemble form: frequency of non-failure years</a:t>
+              <a:t>•  re-evaluation metric: whole-record weekly reliability, per realization</a:t>
             </a:r>
           </a:p>
         </p:txBody>
@@ -32889,7 +33041,7 @@
                 </a:solidFill>
                 <a:latin typeface="Cambria"/>
               </a:rPr>
-              <a:t>f₆ = days any tail gauge ≥ NWS minor flood stage</a:t>
+              <a:t>annual metric = days any tail gauge ≥ NWS minor flood stage, per unit-year</a:t>
             </a:r>
           </a:p>
           <a:p>
@@ -32908,6 +33060,25 @@
                 </a:solidFill>
                 <a:latin typeface="Cambria"/>
               </a:rPr>
+              <a:t>f₆ = mean across pooled unit-years   (expected annual flood days)</a:t>
+            </a:r>
+          </a:p>
+          <a:p>
+            <a:pPr>
+              <a:lnSpc>
+                <a:spcPct val="104000"/>
+              </a:lnSpc>
+              <a:spcAft>
+                <a:spcPts val="600"/>
+              </a:spcAft>
+            </a:pPr>
+            <a:r>
+              <a:rPr sz="2000" i="0" b="0">
+                <a:solidFill>
+                  <a:srgbClr val="212529"/>
+                </a:solidFill>
+                <a:latin typeface="Cambria"/>
+              </a:rPr>
               <a:t>gauges: Hale Eddy, Fishs Eddy, Bridgeville</a:t>
             </a:r>
           </a:p>
@@ -32921,8 +33092,8 @@
         </p:nvSpPr>
         <p:spPr>
           <a:xfrm>
-            <a:off x="548640" y="2560320"/>
-            <a:ext cx="11091672" cy="4069080"/>
+            <a:off x="548640" y="3017520"/>
+            <a:ext cx="11091672" cy="3611880"/>
           </a:xfrm>
           <a:prstGeom prst="rect">
             <a:avLst/>
@@ -32969,7 +33140,7 @@
                 </a:solidFill>
                 <a:latin typeface="Calibri"/>
               </a:rPr>
-              <a:t>•  count-over-threshold avoids the expected-damage trap (Quinn et al. 2017)</a:t>
+              <a:t>•  count-over-threshold avoids the expected-damage trap (Quinn et al. 2017); a P₉₉ variant is registered because an expectation can mask floods</a:t>
             </a:r>
           </a:p>
           <a:p>
@@ -32988,7 +33159,7 @@
                 </a:solidFill>
                 <a:latin typeface="Calibri"/>
               </a:rPr>
-              <a:t>•  ensemble form: mean annual flood days (P99 variant registered)</a:t>
+              <a:t>•  re-evaluation metric: whole-record flood-day count, per realization</a:t>
             </a:r>
           </a:p>
         </p:txBody>
@@ -33145,7 +33316,26 @@
                 </a:solidFill>
                 <a:latin typeface="Cambria"/>
               </a:rPr>
-              <a:t>f₇ = P₅ of daily storage%</a:t>
+              <a:t>annual metric = that unit-year's minimum daily storage%</a:t>
+            </a:r>
+          </a:p>
+          <a:p>
+            <a:pPr>
+              <a:lnSpc>
+                <a:spcPct val="104000"/>
+              </a:lnSpc>
+              <a:spcAft>
+                <a:spcPts val="600"/>
+              </a:spcAft>
+            </a:pPr>
+            <a:r>
+              <a:rPr sz="2000" i="0" b="0">
+                <a:solidFill>
+                  <a:srgbClr val="212529"/>
+                </a:solidFill>
+                <a:latin typeface="Cambria"/>
+              </a:rPr>
+              <a:t>f₇ = P₀₁ across pooled unit-years   (1st-percentile unit-year)</a:t>
             </a:r>
           </a:p>
         </p:txBody>
@@ -33158,8 +33348,8 @@
         </p:nvSpPr>
         <p:spPr>
           <a:xfrm>
-            <a:off x="548640" y="2560320"/>
-            <a:ext cx="11091672" cy="4069080"/>
+            <a:off x="548640" y="3017520"/>
+            <a:ext cx="11091672" cy="3611880"/>
           </a:xfrm>
           <a:prstGeom prst="rect">
             <a:avLst/>
@@ -33206,7 +33396,7 @@
                 </a:solidFill>
                 <a:latin typeface="Calibri"/>
               </a:rPr>
-              <a:t>•  ensemble form: 1st-percentile unit-year of annual minimum storage</a:t>
+              <a:t>•  re-evaluation metric: whole-record P₅ of daily storage%, per realization</a:t>
             </a:r>
           </a:p>
         </p:txBody>

</xml_diff>